<commit_message>
Corrected typos in probability slides
</commit_message>
<xml_diff>
--- a/LectureSlides/03a_ReviewOfProbability.pptx
+++ b/LectureSlides/03a_ReviewOfProbability.pptx
@@ -254,7 +254,7 @@
           <a:p>
             <a:fld id="{68C00587-1FB2-4AD6-90E2-FCB188A5CAEA}" type="datetimeFigureOut">
               <a:rPr lang="en-US" smtClean="0"/>
-              <a:t>9/14/2026</a:t>
+              <a:t>9/15/2026</a:t>
             </a:fld>
             <a:endParaRPr lang="en-US"/>
           </a:p>
@@ -784,7 +784,7 @@
           <a:p>
             <a:fld id="{241EB5C9-1307-BA42-ABA2-0BC069CD8E7F}" type="datetimeFigureOut">
               <a:rPr lang="en-US" smtClean="0"/>
-              <a:t>9/14/2026</a:t>
+              <a:t>9/15/2026</a:t>
             </a:fld>
             <a:endParaRPr lang="en-US"/>
           </a:p>
@@ -952,7 +952,7 @@
           <a:p>
             <a:fld id="{241EB5C9-1307-BA42-ABA2-0BC069CD8E7F}" type="datetimeFigureOut">
               <a:rPr lang="en-US" smtClean="0"/>
-              <a:t>9/14/2026</a:t>
+              <a:t>9/15/2026</a:t>
             </a:fld>
             <a:endParaRPr lang="en-US"/>
           </a:p>
@@ -1130,7 +1130,7 @@
           <a:p>
             <a:fld id="{241EB5C9-1307-BA42-ABA2-0BC069CD8E7F}" type="datetimeFigureOut">
               <a:rPr lang="en-US" smtClean="0"/>
-              <a:t>9/14/2026</a:t>
+              <a:t>9/15/2026</a:t>
             </a:fld>
             <a:endParaRPr lang="en-US"/>
           </a:p>
@@ -1298,7 +1298,7 @@
           <a:p>
             <a:fld id="{241EB5C9-1307-BA42-ABA2-0BC069CD8E7F}" type="datetimeFigureOut">
               <a:rPr lang="en-US" smtClean="0"/>
-              <a:t>9/14/2026</a:t>
+              <a:t>9/15/2026</a:t>
             </a:fld>
             <a:endParaRPr lang="en-US"/>
           </a:p>
@@ -1543,7 +1543,7 @@
           <a:p>
             <a:fld id="{241EB5C9-1307-BA42-ABA2-0BC069CD8E7F}" type="datetimeFigureOut">
               <a:rPr lang="en-US" smtClean="0"/>
-              <a:t>9/14/2026</a:t>
+              <a:t>9/15/2026</a:t>
             </a:fld>
             <a:endParaRPr lang="en-US"/>
           </a:p>
@@ -1828,7 +1828,7 @@
           <a:p>
             <a:fld id="{241EB5C9-1307-BA42-ABA2-0BC069CD8E7F}" type="datetimeFigureOut">
               <a:rPr lang="en-US" smtClean="0"/>
-              <a:t>9/14/2026</a:t>
+              <a:t>9/15/2026</a:t>
             </a:fld>
             <a:endParaRPr lang="en-US"/>
           </a:p>
@@ -2247,7 +2247,7 @@
           <a:p>
             <a:fld id="{241EB5C9-1307-BA42-ABA2-0BC069CD8E7F}" type="datetimeFigureOut">
               <a:rPr lang="en-US" smtClean="0"/>
-              <a:t>9/14/2026</a:t>
+              <a:t>9/15/2026</a:t>
             </a:fld>
             <a:endParaRPr lang="en-US"/>
           </a:p>
@@ -2364,7 +2364,7 @@
           <a:p>
             <a:fld id="{241EB5C9-1307-BA42-ABA2-0BC069CD8E7F}" type="datetimeFigureOut">
               <a:rPr lang="en-US" smtClean="0"/>
-              <a:t>9/14/2026</a:t>
+              <a:t>9/15/2026</a:t>
             </a:fld>
             <a:endParaRPr lang="en-US"/>
           </a:p>
@@ -2459,7 +2459,7 @@
           <a:p>
             <a:fld id="{241EB5C9-1307-BA42-ABA2-0BC069CD8E7F}" type="datetimeFigureOut">
               <a:rPr lang="en-US" smtClean="0"/>
-              <a:t>9/14/2026</a:t>
+              <a:t>9/15/2026</a:t>
             </a:fld>
             <a:endParaRPr lang="en-US"/>
           </a:p>
@@ -2734,7 +2734,7 @@
           <a:p>
             <a:fld id="{241EB5C9-1307-BA42-ABA2-0BC069CD8E7F}" type="datetimeFigureOut">
               <a:rPr lang="en-US" smtClean="0"/>
-              <a:t>9/14/2026</a:t>
+              <a:t>9/15/2026</a:t>
             </a:fld>
             <a:endParaRPr lang="en-US"/>
           </a:p>
@@ -2986,7 +2986,7 @@
           <a:p>
             <a:fld id="{241EB5C9-1307-BA42-ABA2-0BC069CD8E7F}" type="datetimeFigureOut">
               <a:rPr lang="en-US" smtClean="0"/>
-              <a:t>9/14/2026</a:t>
+              <a:t>9/15/2026</a:t>
             </a:fld>
             <a:endParaRPr lang="en-US"/>
           </a:p>
@@ -3197,7 +3197,7 @@
           <a:p>
             <a:fld id="{241EB5C9-1307-BA42-ABA2-0BC069CD8E7F}" type="datetimeFigureOut">
               <a:rPr lang="en-US" smtClean="0"/>
-              <a:t>9/14/2026</a:t>
+              <a:t>9/15/2026</a:t>
             </a:fld>
             <a:endParaRPr lang="en-US"/>
           </a:p>
@@ -4489,7 +4489,7 @@
                       <m:sSup>
                         <m:sSupPr>
                           <m:ctrlPr>
-                            <a:rPr lang="en-US" i="1" smtClean="0">
+                            <a:rPr lang="en-US" b="0" i="1" smtClean="0">
                               <a:latin typeface="Cambria Math" panose="02040503050406030204" pitchFamily="18" charset="0"/>
                             </a:rPr>
                           </m:ctrlPr>
@@ -7204,8 +7204,8 @@
           </a:prstGeom>
         </p:spPr>
       </p:pic>
-      <mc:AlternateContent xmlns:mc="http://schemas.openxmlformats.org/markup-compatibility/2006">
-        <mc:Choice xmlns:a14="http://schemas.microsoft.com/office/drawing/2010/main" Requires="a14">
+      <mc:AlternateContent xmlns:mc="http://schemas.openxmlformats.org/markup-compatibility/2006" xmlns:a14="http://schemas.microsoft.com/office/drawing/2010/main">
+        <mc:Choice Requires="a14">
           <p:sp>
             <p:nvSpPr>
               <p:cNvPr id="10" name="TextBox 9">
@@ -7297,7 +7297,7 @@
                     <m:d>
                       <m:dPr>
                         <m:ctrlPr>
-                          <a:rPr lang="el-GR" sz="2400" i="1">
+                          <a:rPr lang="en-US" sz="2400" i="1">
                             <a:latin typeface="Cambria Math" panose="02040503050406030204" pitchFamily="18" charset="0"/>
                             <a:ea typeface="Cambria Math" panose="02040503050406030204" pitchFamily="18" charset="0"/>
                           </a:rPr>
@@ -7384,7 +7384,7 @@
                         <m:sSub>
                           <m:sSubPr>
                             <m:ctrlPr>
-                              <a:rPr lang="el-GR" sz="2400" i="1">
+                              <a:rPr lang="en-US" sz="2400" b="0" i="1" smtClean="0">
                                 <a:latin typeface="Cambria Math" panose="02040503050406030204" pitchFamily="18" charset="0"/>
                                 <a:ea typeface="Cambria Math" panose="02040503050406030204" pitchFamily="18" charset="0"/>
                               </a:rPr>
@@ -7551,7 +7551,7 @@
             </p:txBody>
           </p:sp>
         </mc:Choice>
-        <mc:Fallback>
+        <mc:Fallback xmlns="">
           <p:sp>
             <p:nvSpPr>
               <p:cNvPr id="10" name="TextBox 9">
@@ -11730,7 +11730,7 @@
                           <m:d>
                             <m:dPr>
                               <m:ctrlPr>
-                                <a:rPr lang="en-US" b="0" i="1" smtClean="0">
+                                <a:rPr lang="en-US" i="1">
                                   <a:latin typeface="Cambria Math" panose="02040503050406030204" pitchFamily="18" charset="0"/>
                                 </a:rPr>
                               </m:ctrlPr>
@@ -12033,7 +12033,7 @@
                           <m:d>
                             <m:dPr>
                               <m:ctrlPr>
-                                <a:rPr lang="en-US" b="0" i="1" smtClean="0">
+                                <a:rPr lang="en-US" i="1">
                                   <a:latin typeface="Cambria Math" panose="02040503050406030204" pitchFamily="18" charset="0"/>
                                 </a:rPr>
                               </m:ctrlPr>
@@ -12457,7 +12457,7 @@
                             <m:accPr>
                               <m:chr m:val="̅"/>
                               <m:ctrlPr>
-                                <a:rPr lang="en-US" i="1" smtClean="0">
+                                <a:rPr lang="en-US" i="1">
                                   <a:latin typeface="Cambria Math" panose="02040503050406030204" pitchFamily="18" charset="0"/>
                                 </a:rPr>
                               </m:ctrlPr>
@@ -18774,8 +18774,8 @@
           </p:sp>
         </mc:Fallback>
       </mc:AlternateContent>
-      <mc:AlternateContent xmlns:mc="http://schemas.openxmlformats.org/markup-compatibility/2006" xmlns:a14="http://schemas.microsoft.com/office/drawing/2010/main">
-        <mc:Choice Requires="a14">
+      <mc:AlternateContent xmlns:mc="http://schemas.openxmlformats.org/markup-compatibility/2006">
+        <mc:Choice xmlns:a14="http://schemas.microsoft.com/office/drawing/2010/main" Requires="a14">
           <p:sp>
             <p:nvSpPr>
               <p:cNvPr id="3" name="Content Placeholder 2"/>
@@ -19293,7 +19293,7 @@
                         <a:rPr lang="en-US" b="0" i="1" smtClean="0">
                           <a:latin typeface="Cambria Math" panose="02040503050406030204" pitchFamily="18" charset="0"/>
                         </a:rPr>
-                        <m:t>=</m:t>
+                        <m:t>~</m:t>
                       </m:r>
                       <m:sSup>
                         <m:sSupPr>
@@ -19351,7 +19351,7 @@
             </p:txBody>
           </p:sp>
         </mc:Choice>
-        <mc:Fallback xmlns="">
+        <mc:Fallback>
           <p:sp>
             <p:nvSpPr>
               <p:cNvPr id="3" name="Content Placeholder 2"/>
@@ -23066,8 +23066,8 @@
           </a:p>
         </p:txBody>
       </p:sp>
-      <mc:AlternateContent xmlns:mc="http://schemas.openxmlformats.org/markup-compatibility/2006" xmlns:a14="http://schemas.microsoft.com/office/drawing/2010/main">
-        <mc:Choice Requires="a14">
+      <mc:AlternateContent xmlns:mc="http://schemas.openxmlformats.org/markup-compatibility/2006">
+        <mc:Choice xmlns:a14="http://schemas.microsoft.com/office/drawing/2010/main" Requires="a14">
           <p:sp>
             <p:nvSpPr>
               <p:cNvPr id="3" name="Content Placeholder 2"/>
@@ -23120,7 +23120,7 @@
                 </a:pPr>
                 <a:r>
                   <a:rPr lang="en-US" dirty="0"/>
-                  <a:t>Probability for any set of events, A, is greater than 0 and less than or equal to 1</a:t>
+                  <a:t>Probability for any set of events, A, is greater than or equal to 0 and less than or equal to 1</a:t>
                 </a:r>
               </a:p>
               <a:p>
@@ -23491,7 +23491,7 @@
             </p:txBody>
           </p:sp>
         </mc:Choice>
-        <mc:Fallback xmlns="">
+        <mc:Fallback>
           <p:sp>
             <p:nvSpPr>
               <p:cNvPr id="3" name="Content Placeholder 2"/>
@@ -23510,7 +23510,7 @@
               <a:blipFill>
                 <a:blip r:embed="rId2"/>
                 <a:stretch>
-                  <a:fillRect l="-815" t="-2479" r="-1037"/>
+                  <a:fillRect l="-815" t="-2479"/>
                 </a:stretch>
               </a:blipFill>
             </p:spPr>

</xml_diff>